<commit_message>
docs et livrables : kit Red Team portable, front en direct, ordre de démarrage Compose
</commit_message>
<xml_diff>
--- a/livrables/Support_presentation_RESILIENCE-ALPHA.pptx
+++ b/livrables/Support_presentation_RESILIENCE-ALPHA.pptx
@@ -116,13 +116,13 @@
   <p:extLst>
     <p:ext uri="{521415D9-36F7-43E2-AB2F-B90AF26B5E84}">
       <p14:sectionLst xmlns:p14="http://schemas.microsoft.com/office/powerpoint/2010/main">
-        <p14:section name="Introduction" id="{7eb465eb-1b8a-a412-e902-cb71ff543f49}">
+        <p14:section name="Introduction" id="{117a5c50-a29b-affb-1490-fff6c0adc472}">
           <p14:sldIdLst>
             <p14:sldId id="256"/>
             <p14:sldId id="257"/>
           </p14:sldIdLst>
         </p14:section>
-        <p14:section name="Solution" id="{9001e5dc-1c45-e773-492d-1bc025abdb18}">
+        <p14:section name="Solution" id="{ed1eda3b-dfca-5034-5eeb-03de7924c891}">
           <p14:sldIdLst>
             <p14:sldId id="258"/>
             <p14:sldId id="259"/>
@@ -130,13 +130,13 @@
             <p14:sldId id="261"/>
           </p14:sldIdLst>
         </p14:section>
-        <p14:section name="Preuves" id="{da29b941-a291-e496-1044-d5a354687a34}">
+        <p14:section name="Preuves" id="{09d976f1-e7fa-508c-914f-de401fb507d3}">
           <p14:sldIdLst>
             <p14:sldId id="262"/>
             <p14:sldId id="263"/>
           </p14:sldIdLst>
         </p14:section>
-        <p14:section name="Conclusion" id="{a7d2ee99-ae91-92b5-4619-a36c38868b9a}">
+        <p14:section name="Conclusion" id="{7c98f8bf-1980-9296-1e3b-80352cae17db}">
           <p14:sldIdLst>
             <p14:sldId id="264"/>
             <p14:sldId id="265"/>
@@ -924,7 +924,7 @@
           <a:p>
             <a:r>
               <a:rPr lang="en-US" dirty="0"/>
-              <a:t>[DREVET, chef de projet] En résumé : notre plateforme est attaquée, elle le voit, elle se répare et elle prouve qu'elle remarche, en moins d'une minute et sans humain. Ne nous croyez pas sur parole : on vous le montre maintenant. → Lancer la démo (docs/08-demo-chaos.md).</a:t>
+              <a:t>[DREVET, chef de projet] En résumé : notre plateforme est attaquée, elle le voit, elle se répare et elle prouve qu'elle remarche, en moins d'une minute et sans humain. Ne nous croyez pas sur parole : on vous le montre maintenant. → Lancer la démo (docs/08-demo-chaos.md). Sur le PC Attaquant : python brute_force.py (kit attack/ copié, cible 192.168.137.1 par défaut). L'attaquant est en mode aveugle : le jury suit la reprise sur le dashboard du PC Hôte.</a:t>
             </a:r>
             <a:endParaRPr lang="en-US" dirty="0"/>
           </a:p>

</xml_diff>